<commit_message>
Rename 罕见病联盟 → Rare2AI across entire codebase
Replace all brand references from "罕见病联盟" / "Rare Disease Alliance"
to "Rare2AI" in 15 files: layout metadata, navbar, page titles,
login/register headings, MCP tools output, CSS comments, README,
and PPT presentation.

Seed data referencing "中国罕见病联盟" (real org) left unchanged.

https://claude.ai/code/session_01Kk4UVCLirCaYMVPoRkP2tP
</commit_message>
<xml_diff>
--- a/rare2ai-introduction.pptx
+++ b/rare2ai-introduction.pptx
@@ -3238,7 +3238,7 @@
               </a:defRPr>
             </a:pPr>
             <a:r>
-              <a:t>罕见病联盟  Rare Disease Alliance</a:t>
+              <a:t>Rare2AI</a:t>
             </a:r>
           </a:p>
         </p:txBody>
@@ -8229,7 +8229,7 @@
               </a:defRPr>
             </a:pPr>
             <a:r>
-              <a:t>rare2ai · 罕见病联盟</a:t>
+              <a:t>Rare2AI</a:t>
             </a:r>
           </a:p>
         </p:txBody>

</xml_diff>